<commit_message>
Add Butterbase + EverOS tech stack slide to pitch deck
Slide 3 covers how Butterbase runs the app (LLM gateway +
durable database with write-through cache) and how EverOS
provides persistent learner memory across sessions.

Co-Authored-By: Claude Opus 4.6 (1M context) <noreply@anthropic.com>
</commit_message>
<xml_diff>
--- a/edublox_pitch.pptx
+++ b/edublox_pitch.pptx
@@ -7,6 +7,7 @@
   <p:sldIdLst>
     <p:sldId id="256" r:id="rId7"/>
     <p:sldId id="257" r:id="rId8"/>
+    <p:sldId id="258" r:id="rId9"/>
   </p:sldIdLst>
   <p:sldSz cx="12191695" cy="6858000" type="screen4x3"/>
   <p:notesSz cx="6858000" cy="9144000"/>
@@ -3747,6 +3748,582 @@
             </a:pPr>
             <a:r>
               <a:t>to each student over time.</a:t>
+            </a:r>
+          </a:p>
+        </p:txBody>
+      </p:sp>
+    </p:spTree>
+  </p:cSld>
+  <p:clrMapOvr>
+    <a:masterClrMapping/>
+  </p:clrMapOvr>
+</p:sld>
+</file>
+
+<file path=ppt/slides/slide3.xml><?xml version="1.0" encoding="utf-8"?>
+<p:sld xmlns:a="http://schemas.openxmlformats.org/drawingml/2006/main" xmlns:p="http://schemas.openxmlformats.org/presentationml/2006/main" xmlns:r="http://schemas.openxmlformats.org/officeDocument/2006/relationships">
+  <p:cSld>
+    <p:bg>
+      <p:bgPr>
+        <a:solidFill>
+          <a:srgbClr val="0F172A"/>
+        </a:solidFill>
+        <a:effectLst/>
+      </p:bgPr>
+    </p:bg>
+    <p:spTree>
+      <p:nvGrpSpPr>
+        <p:cNvPr id="1" name=""/>
+        <p:cNvGrpSpPr/>
+        <p:nvPr/>
+      </p:nvGrpSpPr>
+      <p:grpSpPr/>
+      <p:sp>
+        <p:nvSpPr>
+          <p:cNvPr id="2" name="TextBox 1"/>
+          <p:cNvSpPr txBox="1"/>
+          <p:nvPr/>
+        </p:nvSpPr>
+        <p:spPr>
+          <a:xfrm>
+            <a:off x="731520" y="457200"/>
+            <a:ext cx="10515600" cy="914400"/>
+          </a:xfrm>
+          <a:prstGeom prst="rect">
+            <a:avLst/>
+          </a:prstGeom>
+          <a:noFill/>
+        </p:spPr>
+        <p:txBody>
+          <a:bodyPr wrap="square">
+            <a:spAutoFit/>
+          </a:bodyPr>
+          <a:lstStyle/>
+          <a:p>
+            <a:pPr algn="l">
+              <a:defRPr sz="4800" b="1">
+                <a:solidFill>
+                  <a:srgbClr val="67E8F9"/>
+                </a:solidFill>
+              </a:defRPr>
+            </a:pPr>
+            <a:r>
+              <a:t>EDUBLOX</a:t>
+            </a:r>
+          </a:p>
+        </p:txBody>
+      </p:sp>
+      <p:sp>
+        <p:nvSpPr>
+          <p:cNvPr id="3" name="TextBox 2"/>
+          <p:cNvSpPr txBox="1"/>
+          <p:nvPr/>
+        </p:nvSpPr>
+        <p:spPr>
+          <a:xfrm>
+            <a:off x="731520" y="1188720"/>
+            <a:ext cx="10515600" cy="457200"/>
+          </a:xfrm>
+          <a:prstGeom prst="rect">
+            <a:avLst/>
+          </a:prstGeom>
+          <a:noFill/>
+        </p:spPr>
+        <p:txBody>
+          <a:bodyPr wrap="square">
+            <a:spAutoFit/>
+          </a:bodyPr>
+          <a:lstStyle/>
+          <a:p>
+            <a:pPr algn="l">
+              <a:defRPr sz="2800" b="1">
+                <a:solidFill>
+                  <a:srgbClr val="818CF8"/>
+                </a:solidFill>
+              </a:defRPr>
+            </a:pPr>
+            <a:r>
+              <a:t>How It Works: Butterbase + EverOS</a:t>
+            </a:r>
+          </a:p>
+        </p:txBody>
+      </p:sp>
+      <p:sp>
+        <p:nvSpPr>
+          <p:cNvPr id="4" name="TextBox 3"/>
+          <p:cNvSpPr txBox="1"/>
+          <p:nvPr/>
+        </p:nvSpPr>
+        <p:spPr>
+          <a:xfrm>
+            <a:off x="731520" y="2103120"/>
+            <a:ext cx="4754880" cy="457200"/>
+          </a:xfrm>
+          <a:prstGeom prst="rect">
+            <a:avLst/>
+          </a:prstGeom>
+          <a:noFill/>
+        </p:spPr>
+        <p:txBody>
+          <a:bodyPr wrap="square">
+            <a:spAutoFit/>
+          </a:bodyPr>
+          <a:lstStyle/>
+          <a:p>
+            <a:pPr algn="l">
+              <a:defRPr sz="2000" b="1">
+                <a:solidFill>
+                  <a:srgbClr val="67E8F9"/>
+                </a:solidFill>
+              </a:defRPr>
+            </a:pPr>
+            <a:r>
+              <a:t>Butterbase  --  Runs the App</a:t>
+            </a:r>
+          </a:p>
+          <a:p>
+            <a:pPr>
+              <a:defRPr sz="600" b="0">
+                <a:solidFill>
+                  <a:srgbClr val="FFFFFF"/>
+                </a:solidFill>
+              </a:defRPr>
+            </a:pPr>
+          </a:p>
+          <a:p>
+            <a:pPr>
+              <a:defRPr sz="1400" b="1">
+                <a:solidFill>
+                  <a:srgbClr val="818CF8"/>
+                </a:solidFill>
+              </a:defRPr>
+            </a:pPr>
+            <a:r>
+              <a:t>LLM Gateway</a:t>
+            </a:r>
+          </a:p>
+          <a:p>
+            <a:pPr>
+              <a:defRPr sz="1600" b="0">
+                <a:solidFill>
+                  <a:srgbClr val="FFFFFF"/>
+                </a:solidFill>
+              </a:defRPr>
+            </a:pPr>
+            <a:r>
+              <a:t>All AI calls (plan generation, NPC chat) route through</a:t>
+            </a:r>
+          </a:p>
+          <a:p>
+            <a:pPr>
+              <a:defRPr sz="1600" b="0">
+                <a:solidFill>
+                  <a:srgbClr val="FFFFFF"/>
+                </a:solidFill>
+              </a:defRPr>
+            </a:pPr>
+            <a:r>
+              <a:t>Butterbase. No direct model-provider keys in the app.</a:t>
+            </a:r>
+          </a:p>
+          <a:p>
+            <a:pPr>
+              <a:defRPr sz="800" b="0">
+                <a:solidFill>
+                  <a:srgbClr val="FFFFFF"/>
+                </a:solidFill>
+              </a:defRPr>
+            </a:pPr>
+          </a:p>
+          <a:p>
+            <a:pPr>
+              <a:defRPr sz="1400" b="1">
+                <a:solidFill>
+                  <a:srgbClr val="818CF8"/>
+                </a:solidFill>
+              </a:defRPr>
+            </a:pPr>
+            <a:r>
+              <a:t>Durable Database</a:t>
+            </a:r>
+          </a:p>
+          <a:p>
+            <a:pPr>
+              <a:defRPr sz="1600" b="0">
+                <a:solidFill>
+                  <a:srgbClr val="FFFFFF"/>
+                </a:solidFill>
+              </a:defRPr>
+            </a:pPr>
+            <a:r>
+              <a:t>Persists uploads, plans, sessions, and events.</a:t>
+            </a:r>
+          </a:p>
+          <a:p>
+            <a:pPr>
+              <a:defRPr sz="1600" b="0">
+                <a:solidFill>
+                  <a:srgbClr val="FFFFFF"/>
+                </a:solidFill>
+              </a:defRPr>
+            </a:pPr>
+            <a:r>
+              <a:t>Write-through cache: fast in-memory reads,</a:t>
+            </a:r>
+          </a:p>
+          <a:p>
+            <a:pPr>
+              <a:defRPr sz="1600" b="0">
+                <a:solidFill>
+                  <a:srgbClr val="FFFFFF"/>
+                </a:solidFill>
+              </a:defRPr>
+            </a:pPr>
+            <a:r>
+              <a:t>Butterbase writes for durability. Backend restarts</a:t>
+            </a:r>
+          </a:p>
+          <a:p>
+            <a:pPr>
+              <a:defRPr sz="1600" b="0">
+                <a:solidFill>
+                  <a:srgbClr val="FFFFFF"/>
+                </a:solidFill>
+              </a:defRPr>
+            </a:pPr>
+            <a:r>
+              <a:t>never kill live plan URLs or game sessions.</a:t>
+            </a:r>
+          </a:p>
+          <a:p>
+            <a:pPr>
+              <a:defRPr sz="800" b="0">
+                <a:solidFill>
+                  <a:srgbClr val="FFFFFF"/>
+                </a:solidFill>
+              </a:defRPr>
+            </a:pPr>
+          </a:p>
+          <a:p>
+            <a:pPr>
+              <a:defRPr sz="1400" b="1">
+                <a:solidFill>
+                  <a:srgbClr val="818CF8"/>
+                </a:solidFill>
+              </a:defRPr>
+            </a:pPr>
+            <a:r>
+              <a:t>Resilient by Design</a:t>
+            </a:r>
+          </a:p>
+          <a:p>
+            <a:pPr>
+              <a:defRPr sz="1600" b="0">
+                <a:solidFill>
+                  <a:srgbClr val="FFFFFF"/>
+                </a:solidFill>
+              </a:defRPr>
+            </a:pPr>
+            <a:r>
+              <a:t>Every call is best-effort with short timeouts.</a:t>
+            </a:r>
+          </a:p>
+          <a:p>
+            <a:pPr>
+              <a:defRPr sz="1600" b="0">
+                <a:solidFill>
+                  <a:srgbClr val="FFFFFF"/>
+                </a:solidFill>
+              </a:defRPr>
+            </a:pPr>
+            <a:r>
+              <a:t>If unreachable, app degrades to in-memory only.</a:t>
+            </a:r>
+          </a:p>
+          <a:p>
+            <a:pPr>
+              <a:defRPr sz="1600" b="0">
+                <a:solidFill>
+                  <a:srgbClr val="FFFFFF"/>
+                </a:solidFill>
+              </a:defRPr>
+            </a:pPr>
+            <a:r>
+              <a:t>Gameplay is never blocked.</a:t>
+            </a:r>
+          </a:p>
+        </p:txBody>
+      </p:sp>
+      <p:sp>
+        <p:nvSpPr>
+          <p:cNvPr id="5" name="TextBox 4"/>
+          <p:cNvSpPr txBox="1"/>
+          <p:nvPr/>
+        </p:nvSpPr>
+        <p:spPr>
+          <a:xfrm>
+            <a:off x="6400800" y="2103120"/>
+            <a:ext cx="5029200" cy="457200"/>
+          </a:xfrm>
+          <a:prstGeom prst="rect">
+            <a:avLst/>
+          </a:prstGeom>
+          <a:noFill/>
+        </p:spPr>
+        <p:txBody>
+          <a:bodyPr wrap="square">
+            <a:spAutoFit/>
+          </a:bodyPr>
+          <a:lstStyle/>
+          <a:p>
+            <a:pPr algn="l">
+              <a:defRPr sz="2000" b="1">
+                <a:solidFill>
+                  <a:srgbClr val="67E8F9"/>
+                </a:solidFill>
+              </a:defRPr>
+            </a:pPr>
+            <a:r>
+              <a:t>EverOS  --  Remembers the Learner</a:t>
+            </a:r>
+          </a:p>
+          <a:p>
+            <a:pPr>
+              <a:defRPr sz="600" b="0">
+                <a:solidFill>
+                  <a:srgbClr val="FFFFFF"/>
+                </a:solidFill>
+              </a:defRPr>
+            </a:pPr>
+          </a:p>
+          <a:p>
+            <a:pPr>
+              <a:defRPr sz="1400" b="1">
+                <a:solidFill>
+                  <a:srgbClr val="818CF8"/>
+                </a:solidFill>
+              </a:defRPr>
+            </a:pPr>
+            <a:r>
+              <a:t>Long-Term Learner Memory</a:t>
+            </a:r>
+          </a:p>
+          <a:p>
+            <a:pPr>
+              <a:defRPr sz="1600" b="0">
+                <a:solidFill>
+                  <a:srgbClr val="FFFFFF"/>
+                </a:solidFill>
+              </a:defRPr>
+            </a:pPr>
+            <a:r>
+              <a:t>NPC chat turns and mission milestones are written</a:t>
+            </a:r>
+          </a:p>
+          <a:p>
+            <a:pPr>
+              <a:defRPr sz="1600" b="0">
+                <a:solidFill>
+                  <a:srgbClr val="FFFFFF"/>
+                </a:solidFill>
+              </a:defRPr>
+            </a:pPr>
+            <a:r>
+              <a:t>to EverOS. Its extraction pipeline distills them into</a:t>
+            </a:r>
+          </a:p>
+          <a:p>
+            <a:pPr>
+              <a:defRPr sz="1600" b="0">
+                <a:solidFill>
+                  <a:srgbClr val="FFFFFF"/>
+                </a:solidFill>
+              </a:defRPr>
+            </a:pPr>
+            <a:r>
+              <a:t>a learner profile, traits, interests, and patterns.</a:t>
+            </a:r>
+          </a:p>
+          <a:p>
+            <a:pPr>
+              <a:defRPr sz="800" b="0">
+                <a:solidFill>
+                  <a:srgbClr val="FFFFFF"/>
+                </a:solidFill>
+              </a:defRPr>
+            </a:pPr>
+          </a:p>
+          <a:p>
+            <a:pPr>
+              <a:defRPr sz="1400" b="1">
+                <a:solidFill>
+                  <a:srgbClr val="818CF8"/>
+                </a:solidFill>
+              </a:defRPr>
+            </a:pPr>
+            <a:r>
+              <a:t>Personalized Plans</a:t>
+            </a:r>
+          </a:p>
+          <a:p>
+            <a:pPr>
+              <a:defRPr sz="1600" b="0">
+                <a:solidFill>
+                  <a:srgbClr val="FFFFFF"/>
+                </a:solidFill>
+              </a:defRPr>
+            </a:pPr>
+            <a:r>
+              <a:t>Each new plan runs 3 parallel memory recalls:</a:t>
+            </a:r>
+          </a:p>
+          <a:p>
+            <a:pPr>
+              <a:defRPr sz="1600" b="0">
+                <a:solidFill>
+                  <a:srgbClr val="FFFFFF"/>
+                </a:solidFill>
+              </a:defRPr>
+            </a:pPr>
+            <a:r>
+              <a:t>what they've mastered, where they struggle,</a:t>
+            </a:r>
+          </a:p>
+          <a:p>
+            <a:pPr>
+              <a:defRPr sz="1600" b="0">
+                <a:solidFill>
+                  <a:srgbClr val="FFFFFF"/>
+                </a:solidFill>
+              </a:defRPr>
+            </a:pPr>
+            <a:r>
+              <a:t>and who they are. Session 2 knows Session 1.</a:t>
+            </a:r>
+          </a:p>
+          <a:p>
+            <a:pPr>
+              <a:defRPr sz="800" b="0">
+                <a:solidFill>
+                  <a:srgbClr val="FFFFFF"/>
+                </a:solidFill>
+              </a:defRPr>
+            </a:pPr>
+          </a:p>
+          <a:p>
+            <a:pPr>
+              <a:defRPr sz="1400" b="1">
+                <a:solidFill>
+                  <a:srgbClr val="818CF8"/>
+                </a:solidFill>
+              </a:defRPr>
+            </a:pPr>
+            <a:r>
+              <a:t>Memory Reveal Panel</a:t>
+            </a:r>
+          </a:p>
+          <a:p>
+            <a:pPr>
+              <a:defRPr sz="1600" b="0">
+                <a:solidFill>
+                  <a:srgbClr val="FFFFFF"/>
+                </a:solidFill>
+              </a:defRPr>
+            </a:pPr>
+            <a:r>
+              <a:t>Parents see the exact recalled memory the AI uses.</a:t>
+            </a:r>
+          </a:p>
+          <a:p>
+            <a:pPr>
+              <a:defRPr sz="1600" b="0">
+                <a:solidFill>
+                  <a:srgbClr val="FFFFFF"/>
+                </a:solidFill>
+              </a:defRPr>
+            </a:pPr>
+            <a:r>
+              <a:t>Proves the tutor's memory is real, not scripted.</a:t>
+            </a:r>
+          </a:p>
+          <a:p>
+            <a:pPr>
+              <a:defRPr sz="800" b="0">
+                <a:solidFill>
+                  <a:srgbClr val="FFFFFF"/>
+                </a:solidFill>
+              </a:defRPr>
+            </a:pPr>
+          </a:p>
+          <a:p>
+            <a:pPr>
+              <a:defRPr sz="1400" b="1">
+                <a:solidFill>
+                  <a:srgbClr val="818CF8"/>
+                </a:solidFill>
+              </a:defRPr>
+            </a:pPr>
+            <a:r>
+              <a:t>Never on the Critical Path</a:t>
+            </a:r>
+          </a:p>
+          <a:p>
+            <a:pPr>
+              <a:defRPr sz="1600" b="0">
+                <a:solidFill>
+                  <a:srgbClr val="FFFFFF"/>
+                </a:solidFill>
+              </a:defRPr>
+            </a:pPr>
+            <a:r>
+              <a:t>Writes happen on a background thread. Zero latency</a:t>
+            </a:r>
+          </a:p>
+          <a:p>
+            <a:pPr>
+              <a:defRPr sz="1600" b="0">
+                <a:solidFill>
+                  <a:srgbClr val="FFFFFF"/>
+                </a:solidFill>
+              </a:defRPr>
+            </a:pPr>
+            <a:r>
+              <a:t>added to gameplay. Failed recall = unpersonalized plan.</a:t>
+            </a:r>
+          </a:p>
+        </p:txBody>
+      </p:sp>
+      <p:sp>
+        <p:nvSpPr>
+          <p:cNvPr id="6" name="TextBox 5"/>
+          <p:cNvSpPr txBox="1"/>
+          <p:nvPr/>
+        </p:nvSpPr>
+        <p:spPr>
+          <a:xfrm>
+            <a:off x="731520" y="6035040"/>
+            <a:ext cx="10515600" cy="548640"/>
+          </a:xfrm>
+          <a:prstGeom prst="rect">
+            <a:avLst/>
+          </a:prstGeom>
+          <a:noFill/>
+        </p:spPr>
+        <p:txBody>
+          <a:bodyPr wrap="square">
+            <a:spAutoFit/>
+          </a:bodyPr>
+          <a:lstStyle/>
+          <a:p>
+            <a:pPr algn="ctr">
+              <a:defRPr sz="2000" b="1">
+                <a:solidFill>
+                  <a:srgbClr val="94A3B8"/>
+                </a:solidFill>
+              </a:defRPr>
+            </a:pPr>
+            <a:r>
+              <a:t>Butterbase runs the app.  EverOS makes the tutor remember the child.</a:t>
             </a:r>
           </a:p>
         </p:txBody>

</xml_diff>